<commit_message>
data-eng 6-1 덱 — 실습점검 w6d1s0 신설, s1~s3 실측 반영
Co-Authored-By: Claude Opus 5.5 <noreply@anthropic.com>
</commit_message>
<xml_diff>
--- a/data-eng/decks/w6d1s1.pptx
+++ b/data-eng/decks/w6d1s1.pptx
@@ -3099,7 +3099,7 @@
       <p:grpSpPr/>
       <p:sp>
         <p:nvSpPr>
-          <p:cNvPr id="2" name="Oval 1"/>
+          <p:cNvPr id="2" name="deckgen:decor"/>
           <p:cNvSpPr/>
           <p:nvPr/>
         </p:nvSpPr>
@@ -3129,7 +3129,7 @@
       </p:sp>
       <p:sp>
         <p:nvSpPr>
-          <p:cNvPr id="3" name="Oval 2"/>
+          <p:cNvPr id="3" name="deckgen:decor"/>
           <p:cNvSpPr/>
           <p:nvPr/>
         </p:nvSpPr>
@@ -3159,7 +3159,7 @@
       </p:sp>
       <p:sp>
         <p:nvSpPr>
-          <p:cNvPr id="4" name="Oval 3"/>
+          <p:cNvPr id="4" name="deckgen:decor"/>
           <p:cNvSpPr/>
           <p:nvPr/>
         </p:nvSpPr>
@@ -3189,7 +3189,7 @@
       </p:sp>
       <p:sp>
         <p:nvSpPr>
-          <p:cNvPr id="5" name="Rectangle 4"/>
+          <p:cNvPr id="5" name="deckgen:decor"/>
           <p:cNvSpPr/>
           <p:nvPr/>
         </p:nvSpPr>
@@ -3219,7 +3219,7 @@
       </p:sp>
       <p:sp>
         <p:nvSpPr>
-          <p:cNvPr id="6" name="Oval 5"/>
+          <p:cNvPr id="6" name="deckgen:decor"/>
           <p:cNvSpPr/>
           <p:nvPr/>
         </p:nvSpPr>
@@ -3249,7 +3249,7 @@
       </p:sp>
       <p:sp>
         <p:nvSpPr>
-          <p:cNvPr id="7" name="Oval 6"/>
+          <p:cNvPr id="7" name="deckgen:decor"/>
           <p:cNvSpPr/>
           <p:nvPr/>
         </p:nvSpPr>
@@ -3279,7 +3279,7 @@
       </p:sp>
       <p:sp>
         <p:nvSpPr>
-          <p:cNvPr id="8" name="Oval 7"/>
+          <p:cNvPr id="8" name="deckgen:decor"/>
           <p:cNvSpPr/>
           <p:nvPr/>
         </p:nvSpPr>
@@ -3309,7 +3309,7 @@
       </p:sp>
       <p:sp>
         <p:nvSpPr>
-          <p:cNvPr id="9" name="Oval 8"/>
+          <p:cNvPr id="9" name="deckgen:decor"/>
           <p:cNvSpPr/>
           <p:nvPr/>
         </p:nvSpPr>
@@ -3339,7 +3339,7 @@
       </p:sp>
       <p:sp>
         <p:nvSpPr>
-          <p:cNvPr id="10" name="Rectangle 9"/>
+          <p:cNvPr id="10" name="deckgen:decor"/>
           <p:cNvSpPr/>
           <p:nvPr/>
         </p:nvSpPr>
@@ -3599,7 +3599,7 @@
       <p:grpSpPr/>
       <p:sp>
         <p:nvSpPr>
-          <p:cNvPr id="2" name="Oval 1"/>
+          <p:cNvPr id="2" name="deckgen:decor"/>
           <p:cNvSpPr/>
           <p:nvPr/>
         </p:nvSpPr>
@@ -3629,7 +3629,7 @@
       </p:sp>
       <p:sp>
         <p:nvSpPr>
-          <p:cNvPr id="3" name="Oval 2"/>
+          <p:cNvPr id="3" name="deckgen:decor"/>
           <p:cNvSpPr/>
           <p:nvPr/>
         </p:nvSpPr>
@@ -3852,7 +3852,7 @@
         </p:nvSpPr>
         <p:spPr>
           <a:xfrm>
-            <a:off x="1428750" y="5486400"/>
+            <a:off x="1428750" y="5476875"/>
             <a:ext cx="419100" cy="381000"/>
           </a:xfrm>
           <a:prstGeom prst="rect">
@@ -3893,7 +3893,7 @@
         </p:nvSpPr>
         <p:spPr>
           <a:xfrm>
-            <a:off x="1905000" y="5486400"/>
+            <a:off x="1905000" y="5476875"/>
             <a:ext cx="6724650" cy="381000"/>
           </a:xfrm>
           <a:prstGeom prst="rect">
@@ -3968,7 +3968,7 @@
         </p:nvSpPr>
         <p:spPr>
           <a:xfrm>
-            <a:off x="9658350" y="5486400"/>
+            <a:off x="9658350" y="5476875"/>
             <a:ext cx="419100" cy="381000"/>
           </a:xfrm>
           <a:prstGeom prst="rect">
@@ -4009,7 +4009,7 @@
         </p:nvSpPr>
         <p:spPr>
           <a:xfrm>
-            <a:off x="10134600" y="5486400"/>
+            <a:off x="10134600" y="5476875"/>
             <a:ext cx="6724650" cy="381000"/>
           </a:xfrm>
           <a:prstGeom prst="rect">
@@ -4084,7 +4084,7 @@
         </p:nvSpPr>
         <p:spPr>
           <a:xfrm>
-            <a:off x="1428750" y="6515100"/>
+            <a:off x="1428750" y="6505575"/>
             <a:ext cx="419100" cy="381000"/>
           </a:xfrm>
           <a:prstGeom prst="rect">
@@ -4125,7 +4125,7 @@
         </p:nvSpPr>
         <p:spPr>
           <a:xfrm>
-            <a:off x="1905000" y="6515100"/>
+            <a:off x="1905000" y="6505575"/>
             <a:ext cx="6724650" cy="381000"/>
           </a:xfrm>
           <a:prstGeom prst="rect">
@@ -4200,7 +4200,7 @@
         </p:nvSpPr>
         <p:spPr>
           <a:xfrm>
-            <a:off x="9658350" y="6515100"/>
+            <a:off x="9658350" y="6505575"/>
             <a:ext cx="419100" cy="381000"/>
           </a:xfrm>
           <a:prstGeom prst="rect">
@@ -4241,7 +4241,7 @@
         </p:nvSpPr>
         <p:spPr>
           <a:xfrm>
-            <a:off x="10134600" y="6515100"/>
+            <a:off x="10134600" y="6505575"/>
             <a:ext cx="6724650" cy="381000"/>
           </a:xfrm>
           <a:prstGeom prst="rect">
@@ -4381,7 +4381,7 @@
                 <a:ea typeface="Pretendard"/>
                 <a:cs typeface="Pretendard"/>
               </a:rPr>
-              <a:t>Docker 데몬 실행 상태 · 메모리 8GB 이상</a:t>
+              <a:t>Docker 실행 · Total Memory 7.7GiB 안팎(설정 8GB)</a:t>
             </a:r>
           </a:p>
         </p:txBody>
@@ -4406,7 +4406,7 @@
       <p:grpSpPr/>
       <p:sp>
         <p:nvSpPr>
-          <p:cNvPr id="2" name="Oval 1"/>
+          <p:cNvPr id="2" name="deckgen:decor"/>
           <p:cNvSpPr/>
           <p:nvPr/>
         </p:nvSpPr>
@@ -4436,7 +4436,7 @@
       </p:sp>
       <p:sp>
         <p:nvSpPr>
-          <p:cNvPr id="3" name="Oval 2"/>
+          <p:cNvPr id="3" name="deckgen:decor"/>
           <p:cNvSpPr/>
           <p:nvPr/>
         </p:nvSpPr>
@@ -4466,7 +4466,7 @@
       </p:sp>
       <p:sp>
         <p:nvSpPr>
-          <p:cNvPr id="4" name="Oval 3"/>
+          <p:cNvPr id="4" name="deckgen:decor"/>
           <p:cNvSpPr/>
           <p:nvPr/>
         </p:nvSpPr>
@@ -5397,7 +5397,7 @@
       <p:grpSpPr/>
       <p:sp>
         <p:nvSpPr>
-          <p:cNvPr id="2" name="Oval 1"/>
+          <p:cNvPr id="2" name="deckgen:decor"/>
           <p:cNvSpPr/>
           <p:nvPr/>
         </p:nvSpPr>
@@ -5427,7 +5427,7 @@
       </p:sp>
       <p:sp>
         <p:nvSpPr>
-          <p:cNvPr id="3" name="Oval 2"/>
+          <p:cNvPr id="3" name="deckgen:decor"/>
           <p:cNvSpPr/>
           <p:nvPr/>
         </p:nvSpPr>
@@ -5457,7 +5457,7 @@
       </p:sp>
       <p:sp>
         <p:nvSpPr>
-          <p:cNvPr id="4" name="Oval 3"/>
+          <p:cNvPr id="4" name="deckgen:decor"/>
           <p:cNvSpPr/>
           <p:nvPr/>
         </p:nvSpPr>
@@ -6600,7 +6600,7 @@
       <p:grpSpPr/>
       <p:sp>
         <p:nvSpPr>
-          <p:cNvPr id="2" name="Oval 1"/>
+          <p:cNvPr id="2" name="deckgen:decor"/>
           <p:cNvSpPr/>
           <p:nvPr/>
         </p:nvSpPr>
@@ -6630,7 +6630,7 @@
       </p:sp>
       <p:sp>
         <p:nvSpPr>
-          <p:cNvPr id="3" name="Oval 2"/>
+          <p:cNvPr id="3" name="deckgen:decor"/>
           <p:cNvSpPr/>
           <p:nvPr/>
         </p:nvSpPr>
@@ -6660,7 +6660,7 @@
       </p:sp>
       <p:sp>
         <p:nvSpPr>
-          <p:cNvPr id="4" name="Oval 3"/>
+          <p:cNvPr id="4" name="deckgen:decor"/>
           <p:cNvSpPr/>
           <p:nvPr/>
         </p:nvSpPr>
@@ -8536,7 +8536,7 @@
       <p:grpSpPr/>
       <p:sp>
         <p:nvSpPr>
-          <p:cNvPr id="2" name="Oval 1"/>
+          <p:cNvPr id="2" name="deckgen:decor"/>
           <p:cNvSpPr/>
           <p:nvPr/>
         </p:nvSpPr>
@@ -8566,7 +8566,7 @@
       </p:sp>
       <p:sp>
         <p:nvSpPr>
-          <p:cNvPr id="3" name="Oval 2"/>
+          <p:cNvPr id="3" name="deckgen:decor"/>
           <p:cNvSpPr/>
           <p:nvPr/>
         </p:nvSpPr>
@@ -8596,7 +8596,7 @@
       </p:sp>
       <p:sp>
         <p:nvSpPr>
-          <p:cNvPr id="4" name="Oval 3"/>
+          <p:cNvPr id="4" name="deckgen:decor"/>
           <p:cNvSpPr/>
           <p:nvPr/>
         </p:nvSpPr>
@@ -10472,7 +10472,7 @@
       <p:grpSpPr/>
       <p:sp>
         <p:nvSpPr>
-          <p:cNvPr id="2" name="Oval 1"/>
+          <p:cNvPr id="2" name="deckgen:decor"/>
           <p:cNvSpPr/>
           <p:nvPr/>
         </p:nvSpPr>
@@ -10502,7 +10502,7 @@
       </p:sp>
       <p:sp>
         <p:nvSpPr>
-          <p:cNvPr id="3" name="Oval 2"/>
+          <p:cNvPr id="3" name="deckgen:decor"/>
           <p:cNvSpPr/>
           <p:nvPr/>
         </p:nvSpPr>
@@ -10532,7 +10532,7 @@
       </p:sp>
       <p:sp>
         <p:nvSpPr>
-          <p:cNvPr id="4" name="Oval 3"/>
+          <p:cNvPr id="4" name="deckgen:decor"/>
           <p:cNvSpPr/>
           <p:nvPr/>
         </p:nvSpPr>
@@ -11570,7 +11570,7 @@
       <p:grpSpPr/>
       <p:sp>
         <p:nvSpPr>
-          <p:cNvPr id="2" name="Oval 1"/>
+          <p:cNvPr id="2" name="deckgen:decor"/>
           <p:cNvSpPr/>
           <p:nvPr/>
         </p:nvSpPr>
@@ -11600,7 +11600,7 @@
       </p:sp>
       <p:sp>
         <p:nvSpPr>
-          <p:cNvPr id="3" name="Oval 2"/>
+          <p:cNvPr id="3" name="deckgen:decor"/>
           <p:cNvSpPr/>
           <p:nvPr/>
         </p:nvSpPr>
@@ -11630,7 +11630,7 @@
       </p:sp>
       <p:sp>
         <p:nvSpPr>
-          <p:cNvPr id="4" name="Oval 3"/>
+          <p:cNvPr id="4" name="deckgen:decor"/>
           <p:cNvSpPr/>
           <p:nvPr/>
         </p:nvSpPr>
@@ -12570,7 +12570,7 @@
       <p:grpSpPr/>
       <p:sp>
         <p:nvSpPr>
-          <p:cNvPr id="2" name="Oval 1"/>
+          <p:cNvPr id="2" name="deckgen:decor"/>
           <p:cNvSpPr/>
           <p:nvPr/>
         </p:nvSpPr>
@@ -12600,7 +12600,7 @@
       </p:sp>
       <p:sp>
         <p:nvSpPr>
-          <p:cNvPr id="3" name="Oval 2"/>
+          <p:cNvPr id="3" name="deckgen:decor"/>
           <p:cNvSpPr/>
           <p:nvPr/>
         </p:nvSpPr>
@@ -12630,7 +12630,7 @@
       </p:sp>
       <p:sp>
         <p:nvSpPr>
-          <p:cNvPr id="4" name="Oval 3"/>
+          <p:cNvPr id="4" name="deckgen:decor"/>
           <p:cNvSpPr/>
           <p:nvPr/>
         </p:nvSpPr>
@@ -13631,7 +13631,7 @@
       <p:grpSpPr/>
       <p:sp>
         <p:nvSpPr>
-          <p:cNvPr id="2" name="Oval 1"/>
+          <p:cNvPr id="2" name="deckgen:decor"/>
           <p:cNvSpPr/>
           <p:nvPr/>
         </p:nvSpPr>
@@ -13661,7 +13661,7 @@
       </p:sp>
       <p:sp>
         <p:nvSpPr>
-          <p:cNvPr id="3" name="Oval 2"/>
+          <p:cNvPr id="3" name="deckgen:decor"/>
           <p:cNvSpPr/>
           <p:nvPr/>
         </p:nvSpPr>
@@ -13691,7 +13691,7 @@
       </p:sp>
       <p:sp>
         <p:nvSpPr>
-          <p:cNvPr id="4" name="Oval 3"/>
+          <p:cNvPr id="4" name="deckgen:decor"/>
           <p:cNvSpPr/>
           <p:nvPr/>
         </p:nvSpPr>

</xml_diff>